<commit_message>
feat: add book PDF generation scripts, print templates, and internationalization support
</commit_message>
<xml_diff>
--- a/BookCover.pptx
+++ b/BookCover.pptx
@@ -3013,8 +3013,8 @@
         </p:nvSpPr>
         <p:spPr>
           <a:xfrm>
-            <a:off x="434129" y="818272"/>
-            <a:ext cx="5989739" cy="796517"/>
+            <a:off x="119542" y="865844"/>
+            <a:ext cx="6618914" cy="796517"/>
           </a:xfrm>
           <a:prstGeom prst="rect">
             <a:avLst/>
@@ -3053,7 +3053,7 @@
           <a:p>
             <a:pPr algn="ctr"/>
             <a:r>
-              <a:rPr lang="en-US" sz="4000" b="1" dirty="0">
+              <a:rPr lang="en-US" sz="3600" b="1" dirty="0">
                 <a:gradFill flip="none" rotWithShape="1">
                   <a:gsLst>
                     <a:gs pos="0">
@@ -3089,106 +3089,7 @@
                 <a:ea typeface="ADLaM Display" panose="020F0502020204030204" pitchFamily="2" charset="0"/>
                 <a:cs typeface="Mongolian Baiti" panose="03000500000000000000" pitchFamily="66" charset="0"/>
               </a:rPr>
-              <a:t>FROM DATA TO THESIS</a:t>
-            </a:r>
-          </a:p>
-        </p:txBody>
-      </p:sp>
-      <p:sp>
-        <p:nvSpPr>
-          <p:cNvPr id="7" name="Rectangle 6">
-            <a:extLst>
-              <a:ext uri="{FF2B5EF4-FFF2-40B4-BE49-F238E27FC236}">
-                <a16:creationId xmlns:a16="http://schemas.microsoft.com/office/drawing/2014/main" id="{A820E9CF-D657-21A5-F2D8-DD96BCDC40D3}"/>
-              </a:ext>
-            </a:extLst>
-          </p:cNvPr>
-          <p:cNvSpPr/>
-          <p:nvPr/>
-        </p:nvSpPr>
-        <p:spPr>
-          <a:xfrm>
-            <a:off x="1252057" y="1711354"/>
-            <a:ext cx="4353886" cy="562062"/>
-          </a:xfrm>
-          <a:prstGeom prst="rect">
-            <a:avLst/>
-          </a:prstGeom>
-          <a:gradFill flip="none" rotWithShape="1">
-            <a:gsLst>
-              <a:gs pos="100000">
-                <a:srgbClr val="1E272E"/>
-              </a:gs>
-              <a:gs pos="0">
-                <a:srgbClr val="1B212A"/>
-              </a:gs>
-              <a:gs pos="39000">
-                <a:schemeClr val="bg1">
-                  <a:shade val="67500"/>
-                  <a:satMod val="115000"/>
-                </a:schemeClr>
-              </a:gs>
-              <a:gs pos="66000">
-                <a:schemeClr val="bg1">
-                  <a:shade val="100000"/>
-                  <a:satMod val="115000"/>
-                </a:schemeClr>
-              </a:gs>
-            </a:gsLst>
-            <a:lin ang="0" scaled="0"/>
-            <a:tileRect/>
-          </a:gradFill>
-          <a:ln>
-            <a:noFill/>
-          </a:ln>
-          <a:effectLst>
-            <a:outerShdw blurRad="50800" dist="114300" dir="5400000" algn="t" rotWithShape="0">
-              <a:prstClr val="black">
-                <a:alpha val="40000"/>
-              </a:prstClr>
-            </a:outerShdw>
-          </a:effectLst>
-        </p:spPr>
-        <p:style>
-          <a:lnRef idx="2">
-            <a:schemeClr val="accent1">
-              <a:shade val="15000"/>
-            </a:schemeClr>
-          </a:lnRef>
-          <a:fillRef idx="1">
-            <a:schemeClr val="accent1"/>
-          </a:fillRef>
-          <a:effectRef idx="0">
-            <a:schemeClr val="accent1"/>
-          </a:effectRef>
-          <a:fontRef idx="minor">
-            <a:schemeClr val="lt1"/>
-          </a:fontRef>
-        </p:style>
-        <p:txBody>
-          <a:bodyPr rtlCol="0" anchor="ctr"/>
-          <a:lstStyle/>
-          <a:p>
-            <a:pPr algn="ctr"/>
-            <a:r>
-              <a:rPr lang="en-US" sz="2000" b="1" dirty="0">
-                <a:ln/>
-                <a:solidFill>
-                  <a:srgbClr val="1E272E"/>
-                </a:solidFill>
-                <a:effectLst>
-                  <a:outerShdw blurRad="38100" dist="19050" dir="2700000" algn="tl" rotWithShape="0">
-                    <a:schemeClr val="dk1">
-                      <a:lumMod val="50000"/>
-                      <a:alpha val="40000"/>
-                    </a:schemeClr>
-                  </a:outerShdw>
-                </a:effectLst>
-                <a:latin typeface="Mongolian Baiti" panose="03000500000000000000" pitchFamily="66" charset="0"/>
-                <a:ea typeface="ADLaM Display" panose="020F0502020204030204" pitchFamily="2" charset="0"/>
-                <a:cs typeface="Mongolian Baiti" panose="03000500000000000000" pitchFamily="66" charset="0"/>
-              </a:rPr>
-              <a:t>Using R for Non-technical</a:t>
+              <a:t>Modern Front-End Engineering</a:t>
             </a:r>
           </a:p>
         </p:txBody>
@@ -3277,7 +3178,7 @@
           <a:p>
             <a:pPr lvl="0" algn="ctr"/>
             <a:r>
-              <a:rPr lang="en-US" sz="2000" b="1" dirty="0">
+              <a:rPr lang="en-US" b="1" dirty="0">
                 <a:gradFill flip="none" rotWithShape="1">
                   <a:gsLst>
                     <a:gs pos="0">
@@ -3312,8 +3213,43 @@
                 <a:latin typeface="Bookman Old Style" panose="02050604050505020204" pitchFamily="18" charset="0"/>
                 <a:cs typeface="Posterama" panose="020B0504020200020000" pitchFamily="34" charset="0"/>
               </a:rPr>
-              <a:t>Modern Data Analysis in the Age of AI</a:t>
-            </a:r>
+              <a:t>From Browser Fundamentals to Production Architecture</a:t>
+            </a:r>
+            <a:endParaRPr lang="en-US" sz="2000" b="1" dirty="0">
+              <a:gradFill flip="none" rotWithShape="1">
+                <a:gsLst>
+                  <a:gs pos="0">
+                    <a:schemeClr val="lt1">
+                      <a:shade val="30000"/>
+                      <a:satMod val="115000"/>
+                    </a:schemeClr>
+                  </a:gs>
+                  <a:gs pos="50000">
+                    <a:schemeClr val="lt1">
+                      <a:shade val="67500"/>
+                      <a:satMod val="115000"/>
+                    </a:schemeClr>
+                  </a:gs>
+                  <a:gs pos="100000">
+                    <a:schemeClr val="lt1">
+                      <a:shade val="100000"/>
+                      <a:satMod val="115000"/>
+                    </a:schemeClr>
+                  </a:gs>
+                </a:gsLst>
+                <a:lin ang="8100000" scaled="1"/>
+                <a:tileRect/>
+              </a:gradFill>
+              <a:effectLst>
+                <a:innerShdw blurRad="63500" dist="50800" dir="16200000">
+                  <a:prstClr val="black">
+                    <a:alpha val="50000"/>
+                  </a:prstClr>
+                </a:innerShdw>
+              </a:effectLst>
+              <a:latin typeface="Bookman Old Style" panose="02050604050505020204" pitchFamily="18" charset="0"/>
+              <a:cs typeface="Posterama" panose="020B0504020200020000" pitchFamily="34" charset="0"/>
+            </a:endParaRPr>
           </a:p>
         </p:txBody>
       </p:sp>
@@ -3452,36 +3388,6 @@
           </a:p>
         </p:txBody>
       </p:sp>
-      <p:pic>
-        <p:nvPicPr>
-          <p:cNvPr id="17" name="Picture 16">
-            <a:extLst>
-              <a:ext uri="{FF2B5EF4-FFF2-40B4-BE49-F238E27FC236}">
-                <a16:creationId xmlns:a16="http://schemas.microsoft.com/office/drawing/2014/main" id="{A76AEF4D-7D39-82F0-67DD-07495FC2D166}"/>
-              </a:ext>
-            </a:extLst>
-          </p:cNvPr>
-          <p:cNvPicPr>
-            <a:picLocks noChangeAspect="1"/>
-          </p:cNvPicPr>
-          <p:nvPr/>
-        </p:nvPicPr>
-        <p:blipFill>
-          <a:blip r:embed="rId4"/>
-          <a:stretch>
-            <a:fillRect/>
-          </a:stretch>
-        </p:blipFill>
-        <p:spPr>
-          <a:xfrm>
-            <a:off x="1824863" y="2768239"/>
-            <a:ext cx="3208274" cy="4008913"/>
-          </a:xfrm>
-          <a:prstGeom prst="rect">
-            <a:avLst/>
-          </a:prstGeom>
-        </p:spPr>
-      </p:pic>
       <p:sp>
         <p:nvSpPr>
           <p:cNvPr id="19" name="Rectangle 18">
@@ -3572,6 +3478,48 @@
           </a:p>
         </p:txBody>
       </p:sp>
+      <p:pic>
+        <p:nvPicPr>
+          <p:cNvPr id="21" name="Picture 20">
+            <a:extLst>
+              <a:ext uri="{FF2B5EF4-FFF2-40B4-BE49-F238E27FC236}">
+                <a16:creationId xmlns:a16="http://schemas.microsoft.com/office/drawing/2014/main" id="{388B14FA-021B-A5F6-7C88-D9AB347D84BB}"/>
+              </a:ext>
+            </a:extLst>
+          </p:cNvPr>
+          <p:cNvPicPr>
+            <a:picLocks noChangeAspect="1"/>
+          </p:cNvPicPr>
+          <p:nvPr/>
+        </p:nvPicPr>
+        <p:blipFill>
+          <a:blip r:embed="rId4">
+            <a:extLst>
+              <a:ext uri="{BEBA8EAE-BF5A-486C-A8C5-ECC9F3942E4B}">
+                <a14:imgProps xmlns:a14="http://schemas.microsoft.com/office/drawing/2010/main">
+                  <a14:imgLayer r:embed="rId5">
+                    <a14:imgEffect>
+                      <a14:backgroundRemoval t="10000" b="90000" l="10000" r="90000"/>
+                    </a14:imgEffect>
+                  </a14:imgLayer>
+                </a14:imgProps>
+              </a:ext>
+            </a:extLst>
+          </a:blip>
+          <a:stretch>
+            <a:fillRect/>
+          </a:stretch>
+        </p:blipFill>
+        <p:spPr>
+          <a:xfrm>
+            <a:off x="1153486" y="2585640"/>
+            <a:ext cx="4452457" cy="4452457"/>
+          </a:xfrm>
+          <a:prstGeom prst="rect">
+            <a:avLst/>
+          </a:prstGeom>
+        </p:spPr>
+      </p:pic>
     </p:spTree>
     <p:extLst>
       <p:ext uri="{BB962C8B-B14F-4D97-AF65-F5344CB8AC3E}">
@@ -3789,7 +3737,7 @@
         </p:nvSpPr>
         <p:spPr>
           <a:xfrm>
-            <a:off x="434128" y="32141"/>
+            <a:off x="434126" y="314641"/>
             <a:ext cx="5989739" cy="796517"/>
           </a:xfrm>
           <a:prstGeom prst="rect">
@@ -3845,7 +3793,7 @@
                 <a:ea typeface="Yu Mincho Light" panose="02020300000000000000" pitchFamily="18" charset="-128"/>
                 <a:cs typeface="Mongolian Baiti" panose="03000500000000000000" pitchFamily="66" charset="0"/>
               </a:rPr>
-              <a:t>From Data To Thesis Using R</a:t>
+              <a:t>Modern Front-End Engineering</a:t>
             </a:r>
           </a:p>
         </p:txBody>
@@ -3864,8 +3812,8 @@
         </p:nvSpPr>
         <p:spPr>
           <a:xfrm>
-            <a:off x="241184" y="828658"/>
-            <a:ext cx="6375629" cy="6370975"/>
+            <a:off x="241182" y="1476132"/>
+            <a:ext cx="6375629" cy="5124480"/>
           </a:xfrm>
           <a:prstGeom prst="rect">
             <a:avLst/>
@@ -3878,416 +3826,94 @@
           </a:bodyPr>
           <a:lstStyle/>
           <a:p>
-            <a:pPr marL="0" marR="0" indent="0" algn="l">
-              <a:buNone/>
-            </a:pPr>
-            <a:r>
-              <a:rPr lang="en-US" sz="1200" b="1" i="0" dirty="0">
-                <a:solidFill>
-                  <a:schemeClr val="bg1"/>
-                </a:solidFill>
-                <a:effectLst/>
-                <a:latin typeface="+mn-lt"/>
-              </a:rPr>
-              <a:t>Turn messy data into a defended, publication-ready thesis.</a:t>
-            </a:r>
-            <a:endParaRPr lang="en-US" sz="1200" b="0" i="0" dirty="0">
-              <a:solidFill>
-                <a:schemeClr val="bg1"/>
-              </a:solidFill>
-              <a:effectLst/>
-              <a:latin typeface="+mn-lt"/>
-            </a:endParaRPr>
-          </a:p>
-          <a:p>
-            <a:pPr marL="0" marR="0" indent="0" algn="l">
-              <a:buNone/>
-            </a:pPr>
-            <a:r>
-              <a:rPr lang="en-US" sz="1200" b="0" i="0" dirty="0">
-                <a:solidFill>
-                  <a:schemeClr val="bg1"/>
-                </a:solidFill>
-                <a:effectLst/>
-                <a:latin typeface="+mn-lt"/>
-              </a:rPr>
-              <a:t>For many postgraduate and academic researchers, collecting data is only the beginning of the real challenge. The hardest hurdle is turning spreadsheets, surveys, and lab observations into robust statistical models and defendable written arguments. Commercial point-and-click tools leave your analysis opaque, while standard programming textbooks bury you in abstract computer science theory.</a:t>
-            </a:r>
-          </a:p>
-          <a:p>
-            <a:pPr marL="0" marR="0" indent="0" algn="l">
-              <a:buNone/>
-            </a:pPr>
-            <a:r>
-              <a:rPr lang="en-US" sz="1200" b="1" i="1" dirty="0">
-                <a:solidFill>
-                  <a:schemeClr val="bg1"/>
-                </a:solidFill>
-                <a:effectLst/>
-                <a:latin typeface="+mn-lt"/>
-              </a:rPr>
-              <a:t>From Data to Thesis</a:t>
-            </a:r>
-            <a:r>
-              <a:rPr lang="en-US" sz="1200" b="0" i="0" dirty="0">
-                <a:solidFill>
-                  <a:schemeClr val="bg1"/>
-                </a:solidFill>
-                <a:effectLst/>
-                <a:latin typeface="+mn-lt"/>
-              </a:rPr>
-              <a:t> bridges that divide. Written specifically for graduate students, doctoral researchers, and academic professionals, this book provides a complete, modern roadmap for empirical research using </a:t>
-            </a:r>
-            <a:r>
-              <a:rPr lang="en-US" sz="1200" b="1" i="0" dirty="0">
-                <a:solidFill>
-                  <a:schemeClr val="bg1"/>
-                </a:solidFill>
-                <a:effectLst/>
-                <a:latin typeface="+mn-lt"/>
-              </a:rPr>
-              <a:t>R</a:t>
-            </a:r>
-            <a:r>
-              <a:rPr lang="en-US" sz="1200" b="0" i="0" dirty="0">
-                <a:solidFill>
-                  <a:schemeClr val="bg1"/>
-                </a:solidFill>
-                <a:effectLst/>
-                <a:latin typeface="+mn-lt"/>
-              </a:rPr>
-              <a:t>. Rather than abstract mathematics, every concept is taught through a single, realistic running case study following 600 students across four semesters.</a:t>
-            </a:r>
-          </a:p>
-          <a:p>
-            <a:pPr lvl="1"/>
-            <a:r>
-              <a:rPr lang="en-US" sz="1200" b="1" i="0" dirty="0">
-                <a:solidFill>
-                  <a:schemeClr val="bg1"/>
-                </a:solidFill>
-                <a:effectLst/>
-                <a:latin typeface="+mn-lt"/>
-              </a:rPr>
-              <a:t>Every chapter guides you through five clear steps:</a:t>
-            </a:r>
-            <a:endParaRPr lang="en-US" sz="1200" b="0" i="0" dirty="0">
-              <a:solidFill>
-                <a:schemeClr val="bg1"/>
-              </a:solidFill>
-              <a:effectLst/>
-              <a:latin typeface="+mn-lt"/>
-            </a:endParaRPr>
-          </a:p>
-          <a:p>
-            <a:pPr marL="800100" lvl="1" indent="-342900">
-              <a:buFont typeface="+mj-lt"/>
-              <a:buAutoNum type="arabicPeriod"/>
-            </a:pPr>
-            <a:r>
-              <a:rPr lang="en-US" sz="1200" b="1" i="0" dirty="0">
-                <a:solidFill>
-                  <a:schemeClr val="bg1"/>
-                </a:solidFill>
-                <a:effectLst/>
-                <a:latin typeface="+mn-lt"/>
-              </a:rPr>
-              <a:t>A Concrete Research Question</a:t>
-            </a:r>
-            <a:r>
-              <a:rPr lang="en-US" sz="1200" b="0" i="0" dirty="0">
-                <a:solidFill>
-                  <a:schemeClr val="bg1"/>
-                </a:solidFill>
-                <a:effectLst/>
-                <a:latin typeface="+mn-lt"/>
-              </a:rPr>
-              <a:t>.</a:t>
-            </a:r>
-          </a:p>
-          <a:p>
-            <a:pPr marL="800100" lvl="1" indent="-342900">
-              <a:buFont typeface="+mj-lt"/>
-              <a:buAutoNum type="arabicPeriod"/>
-            </a:pPr>
-            <a:r>
-              <a:rPr lang="en-US" sz="1200" b="1" i="0" dirty="0">
-                <a:solidFill>
-                  <a:schemeClr val="bg1"/>
-                </a:solidFill>
-                <a:effectLst/>
-                <a:latin typeface="+mn-lt"/>
-              </a:rPr>
-              <a:t>A Minimal Working Example</a:t>
-            </a:r>
-            <a:r>
-              <a:rPr lang="en-US" sz="1200" b="0" i="0" dirty="0">
-                <a:solidFill>
-                  <a:schemeClr val="bg1"/>
-                </a:solidFill>
-                <a:effectLst/>
-                <a:latin typeface="+mn-lt"/>
-              </a:rPr>
-              <a:t> .</a:t>
-            </a:r>
-          </a:p>
-          <a:p>
-            <a:pPr marL="800100" lvl="1" indent="-342900">
-              <a:buFont typeface="+mj-lt"/>
-              <a:buAutoNum type="arabicPeriod"/>
-            </a:pPr>
-            <a:r>
-              <a:rPr lang="en-US" sz="1200" b="1" i="0" dirty="0">
-                <a:solidFill>
-                  <a:schemeClr val="bg1"/>
-                </a:solidFill>
-                <a:effectLst/>
-                <a:latin typeface="+mn-lt"/>
-              </a:rPr>
-              <a:t>The Case-Study Analysis</a:t>
-            </a:r>
-            <a:r>
-              <a:rPr lang="en-US" sz="1200" b="0" i="0" dirty="0">
-                <a:solidFill>
-                  <a:schemeClr val="bg1"/>
-                </a:solidFill>
-                <a:effectLst/>
-                <a:latin typeface="+mn-lt"/>
-              </a:rPr>
-              <a:t>.</a:t>
-            </a:r>
-          </a:p>
-          <a:p>
-            <a:pPr marL="800100" lvl="1" indent="-342900">
-              <a:buFont typeface="+mj-lt"/>
-              <a:buAutoNum type="arabicPeriod"/>
-            </a:pPr>
-            <a:r>
-              <a:rPr lang="en-US" sz="1200" b="1" i="0" dirty="0">
-                <a:solidFill>
-                  <a:schemeClr val="bg1"/>
-                </a:solidFill>
-                <a:effectLst/>
-                <a:latin typeface="+mn-lt"/>
-              </a:rPr>
-              <a:t>In Your Field</a:t>
-            </a:r>
-            <a:r>
-              <a:rPr lang="en-US" sz="1200" b="0" i="0" dirty="0">
-                <a:solidFill>
-                  <a:schemeClr val="bg1"/>
-                </a:solidFill>
-                <a:effectLst/>
-                <a:latin typeface="+mn-lt"/>
-              </a:rPr>
-              <a:t>.</a:t>
-            </a:r>
-          </a:p>
-          <a:p>
-            <a:pPr marL="800100" lvl="1" indent="-342900">
-              <a:buFont typeface="+mj-lt"/>
-              <a:buAutoNum type="arabicPeriod"/>
-            </a:pPr>
-            <a:r>
-              <a:rPr lang="en-US" sz="1200" b="1" i="0" dirty="0">
-                <a:solidFill>
-                  <a:schemeClr val="bg1"/>
-                </a:solidFill>
-                <a:effectLst/>
-                <a:latin typeface="+mn-lt"/>
-              </a:rPr>
-              <a:t>Thesis Reporting &amp; Interpretation</a:t>
-            </a:r>
-            <a:r>
-              <a:rPr lang="en-US" sz="1200" b="0" i="0" dirty="0">
-                <a:solidFill>
-                  <a:schemeClr val="bg1"/>
-                </a:solidFill>
-                <a:effectLst/>
-                <a:latin typeface="+mn-lt"/>
-              </a:rPr>
-              <a:t> .</a:t>
-            </a:r>
-          </a:p>
-          <a:p>
-            <a:pPr marL="0" marR="0" indent="0" algn="l">
-              <a:buNone/>
-            </a:pPr>
-            <a:r>
-              <a:rPr lang="en-US" sz="1200" b="0" i="0" dirty="0">
-                <a:solidFill>
-                  <a:schemeClr val="bg1"/>
-                </a:solidFill>
-                <a:effectLst/>
-                <a:latin typeface="+mn-lt"/>
-              </a:rPr>
-              <a:t>From exploratory data analysis and hypothesis testing to mixed-effects models, machine learning, time-series forecasting, and ethical AI assistance, this book gives you the tools, code, and confidence to defend your research with scientific rigor.</a:t>
-            </a:r>
-          </a:p>
-          <a:p>
-            <a:pPr>
-              <a:buNone/>
-            </a:pPr>
-            <a:br>
-              <a:rPr lang="en-US" sz="1200" dirty="0">
+            <a:pPr algn="just"/>
+            <a:r>
+              <a:rPr lang="en-US" sz="1400" b="1" dirty="0">
                 <a:solidFill>
                   <a:schemeClr val="bg1"/>
                 </a:solidFill>
               </a:rPr>
-            </a:br>
-            <a:r>
-              <a:rPr lang="en-US" sz="1200" b="1" i="0" dirty="0">
+              <a:t>Stop treating front-end development as mere script-gluing. Treat it as a rigorous engineering discipline.</a:t>
+            </a:r>
+          </a:p>
+          <a:p>
+            <a:pPr algn="just"/>
+            <a:endParaRPr lang="en-US" sz="1400" dirty="0">
+              <a:solidFill>
+                <a:schemeClr val="bg1"/>
+              </a:solidFill>
+            </a:endParaRPr>
+          </a:p>
+          <a:p>
+            <a:pPr algn="just"/>
+            <a:r>
+              <a:rPr lang="en-US" sz="1400" dirty="0">
                 <a:solidFill>
                   <a:schemeClr val="bg1"/>
                 </a:solidFill>
-                <a:effectLst/>
-                <a:latin typeface="+mn-lt"/>
               </a:rPr>
-              <a:t>Inside you will discover:</a:t>
-            </a:r>
-            <a:endParaRPr lang="en-US" sz="1200" b="0" i="0" dirty="0">
+              <a:t>In today’s hyper-scale web ecosystem, client-side software is no longer a collection of static documents and lightweight scripts; it is a distributed, fault-tolerant, high-performance application platform running on billions of heterogeneous devices.</a:t>
+            </a:r>
+          </a:p>
+          <a:p>
+            <a:pPr algn="just"/>
+            <a:endParaRPr lang="en-US" sz="1400" dirty="0">
               <a:solidFill>
                 <a:schemeClr val="bg1"/>
               </a:solidFill>
-              <a:effectLst/>
-              <a:latin typeface="+mn-lt"/>
             </a:endParaRPr>
           </a:p>
           <a:p>
-            <a:pPr marL="342900" lvl="0" indent="-342900" algn="l">
-              <a:buFont typeface="Wingdings" panose="05000000000000000000" pitchFamily="2" charset="2"/>
-              <a:buChar char="v"/>
-            </a:pPr>
-            <a:r>
-              <a:rPr lang="en-US" sz="1200" b="0" i="0" dirty="0">
+            <a:pPr algn="just"/>
+            <a:r>
+              <a:rPr lang="en-US" sz="1400" dirty="0">
                 <a:solidFill>
                   <a:schemeClr val="bg1"/>
                 </a:solidFill>
-                <a:effectLst/>
-                <a:latin typeface="+mn-lt"/>
               </a:rPr>
-              <a:t>How to clean, reshape, and visualize complex data using modern </a:t>
-            </a:r>
-            <a:r>
-              <a:rPr lang="en-US" sz="1200" b="1" i="0" dirty="0" err="1">
+              <a:t>Written by veteran software architect and researcher Dr. Polla Abdulhamid Fattah, </a:t>
+            </a:r>
+            <a:r>
+              <a:rPr lang="en-US" sz="1400" i="1" dirty="0">
                 <a:solidFill>
                   <a:schemeClr val="bg1"/>
                 </a:solidFill>
-                <a:effectLst/>
-                <a:latin typeface="+mn-lt"/>
               </a:rPr>
-              <a:t>tidyverse</a:t>
-            </a:r>
-            <a:r>
-              <a:rPr lang="en-US" sz="1200" b="0" i="0" dirty="0">
+              <a:t>Modern Front-End Engineering</a:t>
+            </a:r>
+            <a:r>
+              <a:rPr lang="en-US" sz="1400" dirty="0">
                 <a:solidFill>
                   <a:schemeClr val="bg1"/>
                 </a:solidFill>
-                <a:effectLst/>
-                <a:latin typeface="+mn-lt"/>
               </a:rPr>
-              <a:t> workflows.</a:t>
-            </a:r>
-          </a:p>
-          <a:p>
-            <a:pPr marL="342900" lvl="0" indent="-342900" algn="l">
-              <a:buFont typeface="Wingdings" panose="05000000000000000000" pitchFamily="2" charset="2"/>
-              <a:buChar char="v"/>
-            </a:pPr>
-            <a:r>
-              <a:rPr lang="en-US" sz="1200" b="0" i="0" dirty="0">
+              <a:t> bridges the chasm between raw computer science fundamentals and mission-critical production systems. Beginning with low-level browser mechanics, the V8 compilation pipeline, layout trees, event loops, and memory models, this book guides you through modern CSS architecture, typed runtime contracts, reactivity primitives, and rendering topologies (SSR, SSG, streaming RSC). You will explore client-side distributed persistence, real-time sync protocols, offensive security models, micro-frontends, Core Web Vitals performance engineering, and automated resilience testing.</a:t>
+            </a:r>
+          </a:p>
+          <a:p>
+            <a:pPr algn="just"/>
+            <a:endParaRPr lang="en-US" sz="1400" dirty="0">
+              <a:solidFill>
+                <a:schemeClr val="bg1"/>
+              </a:solidFill>
+            </a:endParaRPr>
+          </a:p>
+          <a:p>
+            <a:pPr algn="just"/>
+            <a:r>
+              <a:rPr lang="en-US" sz="1400" dirty="0">
                 <a:solidFill>
                   <a:schemeClr val="bg1"/>
                 </a:solidFill>
-                <a:effectLst/>
-                <a:latin typeface="+mn-lt"/>
               </a:rPr>
-              <a:t>How to choose the right statistical test—and how to diagnose and fix common assumption violations.</a:t>
-            </a:r>
-          </a:p>
-          <a:p>
-            <a:pPr marL="342900" lvl="0" indent="-342900" algn="l">
-              <a:buFont typeface="Wingdings" panose="05000000000000000000" pitchFamily="2" charset="2"/>
-              <a:buChar char="v"/>
+              <a:t>Whether you are designing resilient design systems for multi-team organizations or optimizing milliseconds off First Content, this book provides the mental models, architectural trade-off frameworks, and production patterns required to engineer resilient web applications.</a:t>
+            </a:r>
+          </a:p>
+          <a:p>
+            <a:pPr marL="0" marR="0" indent="0" algn="l">
+              <a:buNone/>
             </a:pPr>
-            <a:r>
-              <a:rPr lang="en-US" sz="1200" b="0" i="0" dirty="0">
-                <a:solidFill>
-                  <a:schemeClr val="bg1"/>
-                </a:solidFill>
-                <a:effectLst/>
-                <a:latin typeface="+mn-lt"/>
-              </a:rPr>
-              <a:t>Practical machine learning and predictive modeling without the computational overwhelm.</a:t>
-            </a:r>
-          </a:p>
-          <a:p>
-            <a:pPr marL="342900" lvl="0" indent="-342900" algn="l">
-              <a:buFont typeface="Wingdings" panose="05000000000000000000" pitchFamily="2" charset="2"/>
-              <a:buChar char="v"/>
-            </a:pPr>
-            <a:r>
-              <a:rPr lang="en-US" sz="1200" b="0" i="0" dirty="0">
-                <a:solidFill>
-                  <a:schemeClr val="bg1"/>
-                </a:solidFill>
-                <a:effectLst/>
-                <a:latin typeface="+mn-lt"/>
-              </a:rPr>
-              <a:t>Reproducible research workflows using </a:t>
-            </a:r>
-            <a:r>
-              <a:rPr lang="en-US" sz="1200" b="1" i="0" dirty="0">
-                <a:solidFill>
-                  <a:schemeClr val="bg1"/>
-                </a:solidFill>
-                <a:effectLst/>
-                <a:latin typeface="+mn-lt"/>
-              </a:rPr>
-              <a:t>Quarto</a:t>
-            </a:r>
-            <a:r>
-              <a:rPr lang="en-US" sz="1200" b="0" i="0" dirty="0">
-                <a:solidFill>
-                  <a:schemeClr val="bg1"/>
-                </a:solidFill>
-                <a:effectLst/>
-                <a:latin typeface="+mn-lt"/>
-              </a:rPr>
-              <a:t> that generate thesis-ready tables and figures.</a:t>
-            </a:r>
-          </a:p>
-          <a:p>
-            <a:pPr marL="342900" lvl="0" indent="-342900" algn="l">
-              <a:buFont typeface="Wingdings" panose="05000000000000000000" pitchFamily="2" charset="2"/>
-              <a:buChar char="v"/>
-            </a:pPr>
-            <a:r>
-              <a:rPr lang="en-US" sz="1200" b="0" i="0" dirty="0">
-                <a:solidFill>
-                  <a:schemeClr val="bg1"/>
-                </a:solidFill>
-                <a:effectLst/>
-                <a:latin typeface="+mn-lt"/>
-              </a:rPr>
-              <a:t>Interactive browser playgrounds to practice every method without installing a single package.</a:t>
-            </a:r>
-          </a:p>
-          <a:p>
-            <a:pPr marL="0" marR="0" indent="0" algn="l">
-              <a:buNone/>
-            </a:pPr>
-            <a:r>
-              <a:rPr lang="en-US" sz="1200" b="0" i="1" dirty="0">
-                <a:solidFill>
-                  <a:schemeClr val="bg1"/>
-                </a:solidFill>
-                <a:effectLst/>
-                <a:latin typeface="+mn-lt"/>
-              </a:rPr>
-              <a:t>Whether you are writing your first Master’s dissertation, completing your doctoral defense, or preparing an empirical journal article, this book is your desk companion from raw data to submitted thesis.</a:t>
-            </a:r>
-            <a:endParaRPr lang="en-US" sz="700" b="0" i="0" dirty="0">
+            <a:endParaRPr lang="en-US" sz="500" b="0" i="0" dirty="0">
               <a:solidFill>
                 <a:schemeClr val="bg1"/>
               </a:solidFill>

</xml_diff>